<commit_message>
PPTX : capture reelle de la landing dans la slide Vitrine
Co-Authored-By: Claude Opus 4.8 <noreply@anthropic.com>
</commit_message>
<xml_diff>
--- a/Presentation Auto-Ecole Bethel.pptx
+++ b/Presentation Auto-Ecole Bethel.pptx
@@ -9701,8 +9701,8 @@
         </p:nvSpPr>
         <p:spPr>
           <a:xfrm>
-            <a:off x="6492240" y="1645920"/>
-            <a:ext cx="5029200" cy="4114800"/>
+            <a:off x="6355080" y="1783080"/>
+            <a:ext cx="5166360" cy="3198685"/>
           </a:xfrm>
           <a:prstGeom prst="roundRect">
             <a:avLst>
@@ -9710,7 +9710,7 @@
             </a:avLst>
           </a:prstGeom>
           <a:solidFill>
-            <a:srgbClr val="E9EEF4"/>
+            <a:srgbClr val="CBD5E1"/>
           </a:solidFill>
           <a:ln>
             <a:noFill/>
@@ -9747,16 +9747,16 @@
         </p:nvSpPr>
         <p:spPr>
           <a:xfrm>
-            <a:off x="6492240" y="1645920"/>
-            <a:ext cx="5029200" cy="1371600"/>
+            <a:off x="6355080" y="1783080"/>
+            <a:ext cx="5166360" cy="292608"/>
           </a:xfrm>
           <a:prstGeom prst="roundRect">
             <a:avLst>
-              <a:gd name="adj" fmla="val 4000"/>
+              <a:gd name="adj" fmla="val 6000"/>
             </a:avLst>
           </a:prstGeom>
           <a:solidFill>
-            <a:srgbClr val="10203A"/>
+            <a:srgbClr val="2A3B52"/>
           </a:solidFill>
           <a:ln>
             <a:noFill/>
@@ -9787,100 +9787,20 @@
       </p:sp>
       <p:sp>
         <p:nvSpPr>
-          <p:cNvPr id="9" name="TextBox 8"/>
-          <p:cNvSpPr txBox="1"/>
-          <p:nvPr/>
-        </p:nvSpPr>
-        <p:spPr>
-          <a:xfrm>
-            <a:off x="6766560" y="1810512"/>
-            <a:ext cx="4480560" cy="320040"/>
-          </a:xfrm>
-          <a:prstGeom prst="rect">
-            <a:avLst/>
-          </a:prstGeom>
-          <a:noFill/>
-        </p:spPr>
-        <p:txBody>
-          <a:bodyPr wrap="square" anchor="t" lIns="0" rIns="0" tIns="0" bIns="0">
-            <a:spAutoFit/>
-          </a:bodyPr>
-          <a:lstStyle/>
-          <a:p>
-            <a:pPr algn="l">
-              <a:lnSpc>
-                <a:spcPct val="100000"/>
-              </a:lnSpc>
-            </a:pPr>
-            <a:r>
-              <a:rPr sz="1200" b="1" i="0">
-                <a:solidFill>
-                  <a:srgbClr val="FFFFFF"/>
-                </a:solidFill>
-                <a:latin typeface="Segoe UI"/>
-              </a:rPr>
-              <a:t>🚗  Auto-École Béthel · Lambaréné</a:t>
-            </a:r>
-          </a:p>
-        </p:txBody>
-      </p:sp>
-      <p:sp>
-        <p:nvSpPr>
-          <p:cNvPr id="10" name="TextBox 9"/>
-          <p:cNvSpPr txBox="1"/>
-          <p:nvPr/>
-        </p:nvSpPr>
-        <p:spPr>
-          <a:xfrm>
-            <a:off x="6766560" y="2176272"/>
-            <a:ext cx="3931920" cy="640080"/>
-          </a:xfrm>
-          <a:prstGeom prst="rect">
-            <a:avLst/>
-          </a:prstGeom>
-          <a:noFill/>
-        </p:spPr>
-        <p:txBody>
-          <a:bodyPr wrap="square" anchor="t" lIns="0" rIns="0" tIns="0" bIns="0">
-            <a:spAutoFit/>
-          </a:bodyPr>
-          <a:lstStyle/>
-          <a:p>
-            <a:pPr algn="l">
-              <a:lnSpc>
-                <a:spcPct val="100000"/>
-              </a:lnSpc>
-            </a:pPr>
-            <a:r>
-              <a:rPr sz="1500" b="1" i="0">
-                <a:solidFill>
-                  <a:srgbClr val="FFFFFF"/>
-                </a:solidFill>
-                <a:latin typeface="Segoe UI"/>
-              </a:rPr>
-              <a:t>Passez votre permis en toute confiance</a:t>
-            </a:r>
-          </a:p>
-        </p:txBody>
-      </p:sp>
-      <p:sp>
-        <p:nvSpPr>
-          <p:cNvPr id="11" name="Rounded Rectangle 10"/>
+          <p:cNvPr id="9" name="Oval 8"/>
           <p:cNvSpPr/>
           <p:nvPr/>
         </p:nvSpPr>
         <p:spPr>
           <a:xfrm>
-            <a:off x="6766560" y="2670048"/>
-            <a:ext cx="1371600" cy="256032"/>
-          </a:xfrm>
-          <a:prstGeom prst="roundRect">
-            <a:avLst>
-              <a:gd name="adj" fmla="val 30000"/>
-            </a:avLst>
+            <a:off x="6519672" y="1883664"/>
+            <a:ext cx="100584" cy="100584"/>
+          </a:xfrm>
+          <a:prstGeom prst="ellipse">
+            <a:avLst/>
           </a:prstGeom>
           <a:solidFill>
-            <a:srgbClr val="C8922A"/>
+            <a:srgbClr val="EF5F5F"/>
           </a:solidFill>
           <a:ln>
             <a:noFill/>
@@ -9911,61 +9831,20 @@
       </p:sp>
       <p:sp>
         <p:nvSpPr>
-          <p:cNvPr id="12" name="TextBox 11"/>
-          <p:cNvSpPr txBox="1"/>
-          <p:nvPr/>
-        </p:nvSpPr>
-        <p:spPr>
-          <a:xfrm>
-            <a:off x="6876288" y="2697480"/>
-            <a:ext cx="1188720" cy="201168"/>
-          </a:xfrm>
-          <a:prstGeom prst="rect">
-            <a:avLst/>
-          </a:prstGeom>
-          <a:noFill/>
-        </p:spPr>
-        <p:txBody>
-          <a:bodyPr wrap="square" anchor="t" lIns="0" rIns="0" tIns="0" bIns="0">
-            <a:spAutoFit/>
-          </a:bodyPr>
-          <a:lstStyle/>
-          <a:p>
-            <a:pPr algn="l">
-              <a:lnSpc>
-                <a:spcPct val="100000"/>
-              </a:lnSpc>
-            </a:pPr>
-            <a:r>
-              <a:rPr sz="900" b="1" i="0">
-                <a:solidFill>
-                  <a:srgbClr val="10203A"/>
-                </a:solidFill>
-                <a:latin typeface="Segoe UI"/>
-              </a:rPr>
-              <a:t>Je m’inscris</a:t>
-            </a:r>
-          </a:p>
-        </p:txBody>
-      </p:sp>
-      <p:sp>
-        <p:nvSpPr>
-          <p:cNvPr id="13" name="Rounded Rectangle 12"/>
+          <p:cNvPr id="10" name="Oval 9"/>
           <p:cNvSpPr/>
           <p:nvPr/>
         </p:nvSpPr>
         <p:spPr>
           <a:xfrm>
-            <a:off x="6766560" y="3246120"/>
-            <a:ext cx="1051560" cy="914400"/>
-          </a:xfrm>
-          <a:prstGeom prst="roundRect">
-            <a:avLst>
-              <a:gd name="adj" fmla="val 10000"/>
-            </a:avLst>
+            <a:off x="6720840" y="1883664"/>
+            <a:ext cx="100584" cy="100584"/>
+          </a:xfrm>
+          <a:prstGeom prst="ellipse">
+            <a:avLst/>
           </a:prstGeom>
           <a:solidFill>
-            <a:srgbClr val="FFFFFF"/>
+            <a:srgbClr val="F4BF4F"/>
           </a:solidFill>
           <a:ln>
             <a:noFill/>
@@ -9996,100 +9875,20 @@
       </p:sp>
       <p:sp>
         <p:nvSpPr>
-          <p:cNvPr id="14" name="TextBox 13"/>
-          <p:cNvSpPr txBox="1"/>
-          <p:nvPr/>
-        </p:nvSpPr>
-        <p:spPr>
-          <a:xfrm>
-            <a:off x="6766560" y="3392424"/>
-            <a:ext cx="1051560" cy="274320"/>
-          </a:xfrm>
-          <a:prstGeom prst="rect">
-            <a:avLst/>
-          </a:prstGeom>
-          <a:noFill/>
-        </p:spPr>
-        <p:txBody>
-          <a:bodyPr wrap="square" anchor="t" lIns="0" rIns="0" tIns="0" bIns="0">
-            <a:spAutoFit/>
-          </a:bodyPr>
-          <a:lstStyle/>
-          <a:p>
-            <a:pPr algn="ctr">
-              <a:lnSpc>
-                <a:spcPct val="100000"/>
-              </a:lnSpc>
-            </a:pPr>
-            <a:r>
-              <a:rPr sz="950" b="1" i="0">
-                <a:solidFill>
-                  <a:srgbClr val="1E3A5F"/>
-                </a:solidFill>
-                <a:latin typeface="Segoe UI"/>
-              </a:rPr>
-              <a:t>Inscr.</a:t>
-            </a:r>
-          </a:p>
-        </p:txBody>
-      </p:sp>
-      <p:sp>
-        <p:nvSpPr>
-          <p:cNvPr id="15" name="TextBox 14"/>
-          <p:cNvSpPr txBox="1"/>
-          <p:nvPr/>
-        </p:nvSpPr>
-        <p:spPr>
-          <a:xfrm>
-            <a:off x="6766560" y="3721608"/>
-            <a:ext cx="1051560" cy="274320"/>
-          </a:xfrm>
-          <a:prstGeom prst="rect">
-            <a:avLst/>
-          </a:prstGeom>
-          <a:noFill/>
-        </p:spPr>
-        <p:txBody>
-          <a:bodyPr wrap="square" anchor="t" lIns="0" rIns="0" tIns="0" bIns="0">
-            <a:spAutoFit/>
-          </a:bodyPr>
-          <a:lstStyle/>
-          <a:p>
-            <a:pPr algn="ctr">
-              <a:lnSpc>
-                <a:spcPct val="100000"/>
-              </a:lnSpc>
-            </a:pPr>
-            <a:r>
-              <a:rPr sz="1200" b="1" i="0">
-                <a:solidFill>
-                  <a:srgbClr val="C8922A"/>
-                </a:solidFill>
-                <a:latin typeface="Segoe UI"/>
-              </a:rPr>
-              <a:t>50k</a:t>
-            </a:r>
-          </a:p>
-        </p:txBody>
-      </p:sp>
-      <p:sp>
-        <p:nvSpPr>
-          <p:cNvPr id="16" name="Rounded Rectangle 15"/>
+          <p:cNvPr id="11" name="Oval 10"/>
           <p:cNvSpPr/>
           <p:nvPr/>
         </p:nvSpPr>
         <p:spPr>
           <a:xfrm>
-            <a:off x="7909560" y="3246120"/>
-            <a:ext cx="1051560" cy="914400"/>
-          </a:xfrm>
-          <a:prstGeom prst="roundRect">
-            <a:avLst>
-              <a:gd name="adj" fmla="val 10000"/>
-            </a:avLst>
+            <a:off x="6922008" y="1883664"/>
+            <a:ext cx="100584" cy="100584"/>
+          </a:xfrm>
+          <a:prstGeom prst="ellipse">
+            <a:avLst/>
           </a:prstGeom>
           <a:solidFill>
-            <a:srgbClr val="FFFFFF"/>
+            <a:srgbClr val="4FC06A"/>
           </a:solidFill>
           <a:ln>
             <a:noFill/>
@@ -10120,100 +9919,22 @@
       </p:sp>
       <p:sp>
         <p:nvSpPr>
-          <p:cNvPr id="17" name="TextBox 16"/>
-          <p:cNvSpPr txBox="1"/>
-          <p:nvPr/>
-        </p:nvSpPr>
-        <p:spPr>
-          <a:xfrm>
-            <a:off x="7909560" y="3392424"/>
-            <a:ext cx="1051560" cy="274320"/>
-          </a:xfrm>
-          <a:prstGeom prst="rect">
-            <a:avLst/>
-          </a:prstGeom>
-          <a:noFill/>
-        </p:spPr>
-        <p:txBody>
-          <a:bodyPr wrap="square" anchor="t" lIns="0" rIns="0" tIns="0" bIns="0">
-            <a:spAutoFit/>
-          </a:bodyPr>
-          <a:lstStyle/>
-          <a:p>
-            <a:pPr algn="ctr">
-              <a:lnSpc>
-                <a:spcPct val="100000"/>
-              </a:lnSpc>
-            </a:pPr>
-            <a:r>
-              <a:rPr sz="950" b="1" i="0">
-                <a:solidFill>
-                  <a:srgbClr val="1E3A5F"/>
-                </a:solidFill>
-                <a:latin typeface="Segoe UI"/>
-              </a:rPr>
-              <a:t>Code</a:t>
-            </a:r>
-          </a:p>
-        </p:txBody>
-      </p:sp>
-      <p:sp>
-        <p:nvSpPr>
-          <p:cNvPr id="18" name="TextBox 17"/>
-          <p:cNvSpPr txBox="1"/>
-          <p:nvPr/>
-        </p:nvSpPr>
-        <p:spPr>
-          <a:xfrm>
-            <a:off x="7909560" y="3721608"/>
-            <a:ext cx="1051560" cy="274320"/>
-          </a:xfrm>
-          <a:prstGeom prst="rect">
-            <a:avLst/>
-          </a:prstGeom>
-          <a:noFill/>
-        </p:spPr>
-        <p:txBody>
-          <a:bodyPr wrap="square" anchor="t" lIns="0" rIns="0" tIns="0" bIns="0">
-            <a:spAutoFit/>
-          </a:bodyPr>
-          <a:lstStyle/>
-          <a:p>
-            <a:pPr algn="ctr">
-              <a:lnSpc>
-                <a:spcPct val="100000"/>
-              </a:lnSpc>
-            </a:pPr>
-            <a:r>
-              <a:rPr sz="1200" b="1" i="0">
-                <a:solidFill>
-                  <a:srgbClr val="C8922A"/>
-                </a:solidFill>
-                <a:latin typeface="Segoe UI"/>
-              </a:rPr>
-              <a:t>75k</a:t>
-            </a:r>
-          </a:p>
-        </p:txBody>
-      </p:sp>
-      <p:sp>
-        <p:nvSpPr>
-          <p:cNvPr id="19" name="Rounded Rectangle 18"/>
+          <p:cNvPr id="12" name="Rounded Rectangle 11"/>
           <p:cNvSpPr/>
           <p:nvPr/>
         </p:nvSpPr>
         <p:spPr>
           <a:xfrm>
-            <a:off x="9052560" y="3246120"/>
-            <a:ext cx="1051560" cy="914400"/>
+            <a:off x="7315200" y="1847088"/>
+            <a:ext cx="3977640" cy="173736"/>
           </a:xfrm>
           <a:prstGeom prst="roundRect">
             <a:avLst>
-              <a:gd name="adj" fmla="val 10000"/>
+              <a:gd name="adj" fmla="val 50000"/>
             </a:avLst>
           </a:prstGeom>
           <a:solidFill>
-            <a:srgbClr val="FFFFFF"/>
+            <a:srgbClr val="1B283A"/>
           </a:solidFill>
           <a:ln>
             <a:noFill/>
@@ -10244,14 +9965,14 @@
       </p:sp>
       <p:sp>
         <p:nvSpPr>
-          <p:cNvPr id="20" name="TextBox 19"/>
+          <p:cNvPr id="13" name="TextBox 12"/>
           <p:cNvSpPr txBox="1"/>
           <p:nvPr/>
         </p:nvSpPr>
         <p:spPr>
           <a:xfrm>
-            <a:off x="9052560" y="3392424"/>
-            <a:ext cx="1051560" cy="274320"/>
+            <a:off x="7452360" y="1851660"/>
+            <a:ext cx="3886200" cy="155448"/>
           </a:xfrm>
           <a:prstGeom prst="rect">
             <a:avLst/>
@@ -10264,33 +9985,57 @@
           </a:bodyPr>
           <a:lstStyle/>
           <a:p>
-            <a:pPr algn="ctr">
+            <a:pPr algn="l">
               <a:lnSpc>
                 <a:spcPct val="100000"/>
               </a:lnSpc>
             </a:pPr>
             <a:r>
-              <a:rPr sz="950" b="1" i="0">
-                <a:solidFill>
-                  <a:srgbClr val="1E3A5F"/>
-                </a:solidFill>
-                <a:latin typeface="Segoe UI"/>
-              </a:rPr>
-              <a:t>Conduite</a:t>
-            </a:r>
-          </a:p>
-        </p:txBody>
-      </p:sp>
-      <p:sp>
-        <p:nvSpPr>
-          <p:cNvPr id="21" name="TextBox 20"/>
+              <a:rPr sz="850" b="0" i="0">
+                <a:solidFill>
+                  <a:srgbClr val="9FB0C6"/>
+                </a:solidFill>
+                <a:latin typeface="Segoe UI"/>
+              </a:rPr>
+              <a:t>auto-ecole-bethel.onrender.com</a:t>
+            </a:r>
+          </a:p>
+        </p:txBody>
+      </p:sp>
+      <p:pic>
+        <p:nvPicPr>
+          <p:cNvPr id="14" name="Picture 13" descr="landing_hero.jpeg"/>
+          <p:cNvPicPr>
+            <a:picLocks noChangeAspect="1"/>
+          </p:cNvPicPr>
+          <p:nvPr/>
+        </p:nvPicPr>
+        <p:blipFill>
+          <a:blip r:embed="rId2"/>
+          <a:stretch>
+            <a:fillRect/>
+          </a:stretch>
+        </p:blipFill>
+        <p:spPr>
+          <a:xfrm>
+            <a:off x="6355080" y="2075688"/>
+            <a:ext cx="5166360" cy="2906077"/>
+          </a:xfrm>
+          <a:prstGeom prst="rect">
+            <a:avLst/>
+          </a:prstGeom>
+        </p:spPr>
+      </p:pic>
+      <p:sp>
+        <p:nvSpPr>
+          <p:cNvPr id="15" name="TextBox 14"/>
           <p:cNvSpPr txBox="1"/>
           <p:nvPr/>
         </p:nvSpPr>
         <p:spPr>
           <a:xfrm>
-            <a:off x="9052560" y="3721608"/>
-            <a:ext cx="1051560" cy="274320"/>
+            <a:off x="6355080" y="5118925"/>
+            <a:ext cx="5166360" cy="320040"/>
           </a:xfrm>
           <a:prstGeom prst="rect">
             <a:avLst/>
@@ -10309,406 +10054,29 @@
               </a:lnSpc>
             </a:pPr>
             <a:r>
-              <a:rPr sz="1200" b="1" i="0">
-                <a:solidFill>
-                  <a:srgbClr val="C8922A"/>
-                </a:solidFill>
-                <a:latin typeface="Segoe UI"/>
-              </a:rPr>
-              <a:t>150k</a:t>
-            </a:r>
-          </a:p>
-        </p:txBody>
-      </p:sp>
-      <p:sp>
-        <p:nvSpPr>
-          <p:cNvPr id="22" name="Rounded Rectangle 21"/>
-          <p:cNvSpPr/>
-          <p:nvPr/>
-        </p:nvSpPr>
-        <p:spPr>
-          <a:xfrm>
-            <a:off x="10195560" y="3246120"/>
-            <a:ext cx="1051560" cy="914400"/>
-          </a:xfrm>
-          <a:prstGeom prst="roundRect">
-            <a:avLst>
-              <a:gd name="adj" fmla="val 10000"/>
-            </a:avLst>
-          </a:prstGeom>
-          <a:solidFill>
-            <a:srgbClr val="FFFFFF"/>
-          </a:solidFill>
-          <a:ln>
-            <a:noFill/>
-          </a:ln>
-          <a:effectLst/>
-        </p:spPr>
-        <p:style>
-          <a:lnRef idx="1">
-            <a:schemeClr val="accent1"/>
-          </a:lnRef>
-          <a:fillRef idx="3">
-            <a:schemeClr val="accent1"/>
-          </a:fillRef>
-          <a:effectRef idx="2">
-            <a:schemeClr val="accent1"/>
-          </a:effectRef>
-          <a:fontRef idx="minor">
-            <a:schemeClr val="lt1"/>
-          </a:fontRef>
-        </p:style>
-        <p:txBody>
-          <a:bodyPr rtlCol="0" anchor="ctr"/>
-          <a:lstStyle/>
-          <a:p>
-            <a:pPr algn="ctr"/>
-          </a:p>
-        </p:txBody>
-      </p:sp>
-      <p:sp>
-        <p:nvSpPr>
-          <p:cNvPr id="23" name="TextBox 22"/>
-          <p:cNvSpPr txBox="1"/>
-          <p:nvPr/>
-        </p:nvSpPr>
-        <p:spPr>
-          <a:xfrm>
-            <a:off x="10195560" y="3392424"/>
-            <a:ext cx="1051560" cy="274320"/>
-          </a:xfrm>
-          <a:prstGeom prst="rect">
-            <a:avLst/>
-          </a:prstGeom>
-          <a:noFill/>
-        </p:spPr>
-        <p:txBody>
-          <a:bodyPr wrap="square" anchor="t" lIns="0" rIns="0" tIns="0" bIns="0">
-            <a:spAutoFit/>
-          </a:bodyPr>
-          <a:lstStyle/>
-          <a:p>
-            <a:pPr algn="ctr">
-              <a:lnSpc>
-                <a:spcPct val="100000"/>
-              </a:lnSpc>
-            </a:pPr>
-            <a:r>
-              <a:rPr sz="950" b="1" i="0">
+              <a:rPr sz="1100" b="0" i="1">
+                <a:solidFill>
+                  <a:srgbClr val="64748B"/>
+                </a:solidFill>
+                <a:latin typeface="Segoe UI"/>
+              </a:rPr>
+              <a:t>Page d’accueil publique en ligne — </a:t>
+            </a:r>
+            <a:r>
+              <a:rPr sz="1100" b="1" i="0">
                 <a:solidFill>
                   <a:srgbClr val="1E3A5F"/>
                 </a:solidFill>
                 <a:latin typeface="Segoe UI"/>
               </a:rPr>
-              <a:t>Permis</a:t>
-            </a:r>
-          </a:p>
-        </p:txBody>
-      </p:sp>
-      <p:sp>
-        <p:nvSpPr>
-          <p:cNvPr id="24" name="TextBox 23"/>
-          <p:cNvSpPr txBox="1"/>
-          <p:nvPr/>
-        </p:nvSpPr>
-        <p:spPr>
-          <a:xfrm>
-            <a:off x="10195560" y="3721608"/>
-            <a:ext cx="1051560" cy="274320"/>
-          </a:xfrm>
-          <a:prstGeom prst="rect">
-            <a:avLst/>
-          </a:prstGeom>
-          <a:noFill/>
-        </p:spPr>
-        <p:txBody>
-          <a:bodyPr wrap="square" anchor="t" lIns="0" rIns="0" tIns="0" bIns="0">
-            <a:spAutoFit/>
-          </a:bodyPr>
-          <a:lstStyle/>
-          <a:p>
-            <a:pPr algn="ctr">
-              <a:lnSpc>
-                <a:spcPct val="100000"/>
-              </a:lnSpc>
-            </a:pPr>
-            <a:r>
-              <a:rPr sz="1200" b="1" i="0">
-                <a:solidFill>
-                  <a:srgbClr val="C8922A"/>
-                </a:solidFill>
-                <a:latin typeface="Segoe UI"/>
-              </a:rPr>
-              <a:t>250k</a:t>
-            </a:r>
-          </a:p>
-        </p:txBody>
-      </p:sp>
-      <p:sp>
-        <p:nvSpPr>
-          <p:cNvPr id="25" name="Rounded Rectangle 24"/>
-          <p:cNvSpPr/>
-          <p:nvPr/>
-        </p:nvSpPr>
-        <p:spPr>
-          <a:xfrm>
-            <a:off x="6766560" y="4389120"/>
-            <a:ext cx="4480560" cy="1097280"/>
-          </a:xfrm>
-          <a:prstGeom prst="roundRect">
-            <a:avLst>
-              <a:gd name="adj" fmla="val 6000"/>
-            </a:avLst>
-          </a:prstGeom>
-          <a:solidFill>
-            <a:srgbClr val="1E3A5F"/>
-          </a:solidFill>
-          <a:ln>
-            <a:noFill/>
-          </a:ln>
-          <a:effectLst/>
-        </p:spPr>
-        <p:style>
-          <a:lnRef idx="1">
-            <a:schemeClr val="accent1"/>
-          </a:lnRef>
-          <a:fillRef idx="3">
-            <a:schemeClr val="accent1"/>
-          </a:fillRef>
-          <a:effectRef idx="2">
-            <a:schemeClr val="accent1"/>
-          </a:effectRef>
-          <a:fontRef idx="minor">
-            <a:schemeClr val="lt1"/>
-          </a:fontRef>
-        </p:style>
-        <p:txBody>
-          <a:bodyPr rtlCol="0" anchor="ctr"/>
-          <a:lstStyle/>
-          <a:p>
-            <a:pPr algn="ctr"/>
-          </a:p>
-        </p:txBody>
-      </p:sp>
-      <p:sp>
-        <p:nvSpPr>
-          <p:cNvPr id="26" name="TextBox 25"/>
-          <p:cNvSpPr txBox="1"/>
-          <p:nvPr/>
-        </p:nvSpPr>
-        <p:spPr>
-          <a:xfrm>
-            <a:off x="6949440" y="4498848"/>
-            <a:ext cx="4114800" cy="274320"/>
-          </a:xfrm>
-          <a:prstGeom prst="rect">
-            <a:avLst/>
-          </a:prstGeom>
-          <a:noFill/>
-        </p:spPr>
-        <p:txBody>
-          <a:bodyPr wrap="square" anchor="t" lIns="0" rIns="0" tIns="0" bIns="0">
-            <a:spAutoFit/>
-          </a:bodyPr>
-          <a:lstStyle/>
-          <a:p>
-            <a:pPr algn="l">
-              <a:lnSpc>
-                <a:spcPct val="100000"/>
-              </a:lnSpc>
-            </a:pPr>
-            <a:r>
-              <a:rPr sz="1050" b="1" i="0">
-                <a:solidFill>
-                  <a:srgbClr val="C8922A"/>
-                </a:solidFill>
-                <a:latin typeface="Segoe UI"/>
-              </a:rPr>
-              <a:t>Pré-inscription en ligne</a:t>
-            </a:r>
-          </a:p>
-        </p:txBody>
-      </p:sp>
-      <p:sp>
-        <p:nvSpPr>
-          <p:cNvPr id="27" name="Rounded Rectangle 26"/>
-          <p:cNvSpPr/>
-          <p:nvPr/>
-        </p:nvSpPr>
-        <p:spPr>
-          <a:xfrm>
-            <a:off x="6949440" y="4846320"/>
-            <a:ext cx="2011680" cy="274320"/>
-          </a:xfrm>
-          <a:prstGeom prst="roundRect">
-            <a:avLst>
-              <a:gd name="adj" fmla="val 20000"/>
-            </a:avLst>
-          </a:prstGeom>
-          <a:solidFill>
-            <a:srgbClr val="FFFFFF"/>
-          </a:solidFill>
-          <a:ln>
-            <a:noFill/>
-          </a:ln>
-          <a:effectLst/>
-        </p:spPr>
-        <p:style>
-          <a:lnRef idx="1">
-            <a:schemeClr val="accent1"/>
-          </a:lnRef>
-          <a:fillRef idx="3">
-            <a:schemeClr val="accent1"/>
-          </a:fillRef>
-          <a:effectRef idx="2">
-            <a:schemeClr val="accent1"/>
-          </a:effectRef>
-          <a:fontRef idx="minor">
-            <a:schemeClr val="lt1"/>
-          </a:fontRef>
-        </p:style>
-        <p:txBody>
-          <a:bodyPr rtlCol="0" anchor="ctr"/>
-          <a:lstStyle/>
-          <a:p>
-            <a:pPr algn="ctr"/>
-          </a:p>
-        </p:txBody>
-      </p:sp>
-      <p:sp>
-        <p:nvSpPr>
-          <p:cNvPr id="28" name="Rounded Rectangle 27"/>
-          <p:cNvSpPr/>
-          <p:nvPr/>
-        </p:nvSpPr>
-        <p:spPr>
-          <a:xfrm>
-            <a:off x="9098280" y="4846320"/>
-            <a:ext cx="1828800" cy="274320"/>
-          </a:xfrm>
-          <a:prstGeom prst="roundRect">
-            <a:avLst>
-              <a:gd name="adj" fmla="val 20000"/>
-            </a:avLst>
-          </a:prstGeom>
-          <a:solidFill>
-            <a:srgbClr val="FFFFFF"/>
-          </a:solidFill>
-          <a:ln>
-            <a:noFill/>
-          </a:ln>
-          <a:effectLst/>
-        </p:spPr>
-        <p:style>
-          <a:lnRef idx="1">
-            <a:schemeClr val="accent1"/>
-          </a:lnRef>
-          <a:fillRef idx="3">
-            <a:schemeClr val="accent1"/>
-          </a:fillRef>
-          <a:effectRef idx="2">
-            <a:schemeClr val="accent1"/>
-          </a:effectRef>
-          <a:fontRef idx="minor">
-            <a:schemeClr val="lt1"/>
-          </a:fontRef>
-        </p:style>
-        <p:txBody>
-          <a:bodyPr rtlCol="0" anchor="ctr"/>
-          <a:lstStyle/>
-          <a:p>
-            <a:pPr algn="ctr"/>
-          </a:p>
-        </p:txBody>
-      </p:sp>
-      <p:sp>
-        <p:nvSpPr>
-          <p:cNvPr id="29" name="Rounded Rectangle 28"/>
-          <p:cNvSpPr/>
-          <p:nvPr/>
-        </p:nvSpPr>
-        <p:spPr>
-          <a:xfrm>
-            <a:off x="6949440" y="5212080"/>
-            <a:ext cx="1463040" cy="274320"/>
-          </a:xfrm>
-          <a:prstGeom prst="roundRect">
-            <a:avLst>
-              <a:gd name="adj" fmla="val 20000"/>
-            </a:avLst>
-          </a:prstGeom>
-          <a:solidFill>
-            <a:srgbClr val="C8922A"/>
-          </a:solidFill>
-          <a:ln>
-            <a:noFill/>
-          </a:ln>
-          <a:effectLst/>
-        </p:spPr>
-        <p:style>
-          <a:lnRef idx="1">
-            <a:schemeClr val="accent1"/>
-          </a:lnRef>
-          <a:fillRef idx="3">
-            <a:schemeClr val="accent1"/>
-          </a:fillRef>
-          <a:effectRef idx="2">
-            <a:schemeClr val="accent1"/>
-          </a:effectRef>
-          <a:fontRef idx="minor">
-            <a:schemeClr val="lt1"/>
-          </a:fontRef>
-        </p:style>
-        <p:txBody>
-          <a:bodyPr rtlCol="0" anchor="ctr"/>
-          <a:lstStyle/>
-          <a:p>
-            <a:pPr algn="ctr"/>
-          </a:p>
-        </p:txBody>
-      </p:sp>
-      <p:sp>
-        <p:nvSpPr>
-          <p:cNvPr id="30" name="TextBox 29"/>
-          <p:cNvSpPr txBox="1"/>
-          <p:nvPr/>
-        </p:nvSpPr>
-        <p:spPr>
-          <a:xfrm>
-            <a:off x="6949440" y="5239512"/>
-            <a:ext cx="1463040" cy="219456"/>
-          </a:xfrm>
-          <a:prstGeom prst="rect">
-            <a:avLst/>
-          </a:prstGeom>
-          <a:noFill/>
-        </p:spPr>
-        <p:txBody>
-          <a:bodyPr wrap="square" anchor="t" lIns="0" rIns="0" tIns="0" bIns="0">
-            <a:spAutoFit/>
-          </a:bodyPr>
-          <a:lstStyle/>
-          <a:p>
-            <a:pPr algn="ctr">
-              <a:lnSpc>
-                <a:spcPct val="100000"/>
-              </a:lnSpc>
-            </a:pPr>
-            <a:r>
-              <a:rPr sz="900" b="1" i="0">
-                <a:solidFill>
-                  <a:srgbClr val="10203A"/>
-                </a:solidFill>
-                <a:latin typeface="Segoe UI"/>
-              </a:rPr>
-              <a:t>Envoyer</a:t>
-            </a:r>
-          </a:p>
-        </p:txBody>
-      </p:sp>
-      <p:sp>
-        <p:nvSpPr>
-          <p:cNvPr id="31" name="TextBox 30"/>
+              <a:t>vue réelle du site</a:t>
+            </a:r>
+          </a:p>
+        </p:txBody>
+      </p:sp>
+      <p:sp>
+        <p:nvSpPr>
+          <p:cNvPr id="16" name="TextBox 15"/>
           <p:cNvSpPr txBox="1"/>
           <p:nvPr/>
         </p:nvSpPr>

</xml_diff>